<commit_message>
made powerpoint slides for chris
</commit_message>
<xml_diff>
--- a/Chris_workspace/Chris slides.pptx
+++ b/Chris_workspace/Chris slides.pptx
@@ -6,7 +6,10 @@
   </p:sldMasterIdLst>
   <p:sldIdLst>
     <p:sldId id="256" r:id="rId2"/>
-    <p:sldId id="257" r:id="rId3"/>
+    <p:sldId id="259" r:id="rId3"/>
+    <p:sldId id="262" r:id="rId4"/>
+    <p:sldId id="260" r:id="rId5"/>
+    <p:sldId id="263" r:id="rId6"/>
   </p:sldIdLst>
   <p:sldSz cx="12192000" cy="6858000"/>
   <p:notesSz cx="6858000" cy="9144000"/>
@@ -105,7 +108,386 @@
       </a:defRPr>
     </a:lvl9pPr>
   </p:defaultTextStyle>
+  <p:extLst>
+    <p:ext uri="{EFAFB233-063F-42B5-8137-9DF3F51BA10A}">
+      <p15:sldGuideLst xmlns:p15="http://schemas.microsoft.com/office/powerpoint/2012/main"/>
+    </p:ext>
+  </p:extLst>
 </p:presentation>
+</file>
+
+<file path=ppt/revisionInfo.xml><?xml version="1.0" encoding="utf-8"?>
+<p1510:revInfo xmlns:a="http://schemas.openxmlformats.org/drawingml/2006/main" xmlns:r="http://schemas.openxmlformats.org/officeDocument/2006/relationships" xmlns:p1510="http://schemas.microsoft.com/office/powerpoint/2015/10/main">
+  <p1510:revLst>
+    <p1510:client id="{E882A5E6-79E0-42F3-8F3C-5972423F9718}" v="8" dt="2026-06-05T08:37:55.569"/>
+  </p1510:revLst>
+</p1510:revInfo>
+</file>
+
+<file path=ppt/changesInfos/changesInfo1.xml><?xml version="1.0" encoding="utf-8"?>
+<pc:chgInfo xmlns:a="http://schemas.openxmlformats.org/drawingml/2006/main" xmlns:r="http://schemas.openxmlformats.org/officeDocument/2006/relationships" xmlns:ac="http://schemas.microsoft.com/office/drawing/2013/main/command" xmlns:pc="http://schemas.microsoft.com/office/powerpoint/2013/main/command">
+  <pc:docChgLst>
+    <pc:chgData name="Ludvig Pio" userId="9a89843c4959cd87" providerId="LiveId" clId="{874AE5E9-C85C-43CB-8B21-6910BDEE7130}"/>
+    <pc:docChg chg="custSel addSld delSld modSld">
+      <pc:chgData name="Ludvig Pio" userId="9a89843c4959cd87" providerId="LiveId" clId="{874AE5E9-C85C-43CB-8B21-6910BDEE7130}" dt="2026-06-05T08:46:15.087" v="242" actId="1076"/>
+      <pc:docMkLst>
+        <pc:docMk/>
+      </pc:docMkLst>
+      <pc:sldChg chg="delSp modSp mod">
+        <pc:chgData name="Ludvig Pio" userId="9a89843c4959cd87" providerId="LiveId" clId="{874AE5E9-C85C-43CB-8B21-6910BDEE7130}" dt="2026-06-05T08:21:11.225" v="46" actId="14100"/>
+        <pc:sldMkLst>
+          <pc:docMk/>
+          <pc:sldMk cId="811621888" sldId="256"/>
+        </pc:sldMkLst>
+        <pc:spChg chg="mod">
+          <ac:chgData name="Ludvig Pio" userId="9a89843c4959cd87" providerId="LiveId" clId="{874AE5E9-C85C-43CB-8B21-6910BDEE7130}" dt="2026-06-05T08:20:51.918" v="38" actId="113"/>
+          <ac:spMkLst>
+            <pc:docMk/>
+            <pc:sldMk cId="811621888" sldId="256"/>
+            <ac:spMk id="2" creationId="{CEF64FA8-3842-E5A3-1063-EE29DAAF9A91}"/>
+          </ac:spMkLst>
+        </pc:spChg>
+        <pc:spChg chg="mod">
+          <ac:chgData name="Ludvig Pio" userId="9a89843c4959cd87" providerId="LiveId" clId="{874AE5E9-C85C-43CB-8B21-6910BDEE7130}" dt="2026-06-05T08:20:46.532" v="36" actId="20577"/>
+          <ac:spMkLst>
+            <pc:docMk/>
+            <pc:sldMk cId="811621888" sldId="256"/>
+            <ac:spMk id="3" creationId="{4AF78DC5-B088-7855-B96F-CE902904BF84}"/>
+          </ac:spMkLst>
+        </pc:spChg>
+        <pc:picChg chg="mod">
+          <ac:chgData name="Ludvig Pio" userId="9a89843c4959cd87" providerId="LiveId" clId="{874AE5E9-C85C-43CB-8B21-6910BDEE7130}" dt="2026-06-05T08:21:11.225" v="46" actId="14100"/>
+          <ac:picMkLst>
+            <pc:docMk/>
+            <pc:sldMk cId="811621888" sldId="256"/>
+            <ac:picMk id="7" creationId="{E339F70A-2842-922F-DBA2-D3E4DCC4D579}"/>
+          </ac:picMkLst>
+        </pc:picChg>
+        <pc:picChg chg="del mod">
+          <ac:chgData name="Ludvig Pio" userId="9a89843c4959cd87" providerId="LiveId" clId="{874AE5E9-C85C-43CB-8B21-6910BDEE7130}" dt="2026-06-05T08:20:26.982" v="9" actId="478"/>
+          <ac:picMkLst>
+            <pc:docMk/>
+            <pc:sldMk cId="811621888" sldId="256"/>
+            <ac:picMk id="9" creationId="{06C65975-B78E-C8AE-82EE-D71DAA1BC71E}"/>
+          </ac:picMkLst>
+        </pc:picChg>
+      </pc:sldChg>
+      <pc:sldChg chg="addSp modSp del mod">
+        <pc:chgData name="Ludvig Pio" userId="9a89843c4959cd87" providerId="LiveId" clId="{874AE5E9-C85C-43CB-8B21-6910BDEE7130}" dt="2026-06-05T08:26:43.687" v="172" actId="47"/>
+        <pc:sldMkLst>
+          <pc:docMk/>
+          <pc:sldMk cId="549751496" sldId="257"/>
+        </pc:sldMkLst>
+        <pc:picChg chg="mod">
+          <ac:chgData name="Ludvig Pio" userId="9a89843c4959cd87" providerId="LiveId" clId="{874AE5E9-C85C-43CB-8B21-6910BDEE7130}" dt="2026-06-05T08:19:28.729" v="2" actId="1076"/>
+          <ac:picMkLst>
+            <pc:docMk/>
+            <pc:sldMk cId="549751496" sldId="257"/>
+            <ac:picMk id="4" creationId="{81DA7B68-43E1-5A0B-0EF4-DA66C78A7966}"/>
+          </ac:picMkLst>
+        </pc:picChg>
+        <pc:picChg chg="add mod">
+          <ac:chgData name="Ludvig Pio" userId="9a89843c4959cd87" providerId="LiveId" clId="{874AE5E9-C85C-43CB-8B21-6910BDEE7130}" dt="2026-06-05T08:20:19.854" v="8"/>
+          <ac:picMkLst>
+            <pc:docMk/>
+            <pc:sldMk cId="549751496" sldId="257"/>
+            <ac:picMk id="5" creationId="{8B903705-F5B5-0E54-01B1-39B41D62B9A0}"/>
+          </ac:picMkLst>
+        </pc:picChg>
+      </pc:sldChg>
+      <pc:sldChg chg="addSp delSp modSp new del mod setBg">
+        <pc:chgData name="Ludvig Pio" userId="9a89843c4959cd87" providerId="LiveId" clId="{874AE5E9-C85C-43CB-8B21-6910BDEE7130}" dt="2026-06-05T08:26:45.801" v="173" actId="47"/>
+        <pc:sldMkLst>
+          <pc:docMk/>
+          <pc:sldMk cId="1014079325" sldId="258"/>
+        </pc:sldMkLst>
+        <pc:spChg chg="mod">
+          <ac:chgData name="Ludvig Pio" userId="9a89843c4959cd87" providerId="LiveId" clId="{874AE5E9-C85C-43CB-8B21-6910BDEE7130}" dt="2026-06-05T08:19:50.179" v="5" actId="26606"/>
+          <ac:spMkLst>
+            <pc:docMk/>
+            <pc:sldMk cId="1014079325" sldId="258"/>
+            <ac:spMk id="2" creationId="{6EB88EE8-8EAE-E4FD-D64D-685304E5570D}"/>
+          </ac:spMkLst>
+        </pc:spChg>
+        <pc:spChg chg="del">
+          <ac:chgData name="Ludvig Pio" userId="9a89843c4959cd87" providerId="LiveId" clId="{874AE5E9-C85C-43CB-8B21-6910BDEE7130}" dt="2026-06-05T08:19:44.207" v="4"/>
+          <ac:spMkLst>
+            <pc:docMk/>
+            <pc:sldMk cId="1014079325" sldId="258"/>
+            <ac:spMk id="3" creationId="{AB44EF8F-D6B1-86F0-0F46-B07F7E20A66A}"/>
+          </ac:spMkLst>
+        </pc:spChg>
+        <pc:spChg chg="add">
+          <ac:chgData name="Ludvig Pio" userId="9a89843c4959cd87" providerId="LiveId" clId="{874AE5E9-C85C-43CB-8B21-6910BDEE7130}" dt="2026-06-05T08:19:50.179" v="5" actId="26606"/>
+          <ac:spMkLst>
+            <pc:docMk/>
+            <pc:sldMk cId="1014079325" sldId="258"/>
+            <ac:spMk id="8" creationId="{EBC9623C-D855-4C60-C1D7-ACDECD94223A}"/>
+          </ac:spMkLst>
+        </pc:spChg>
+        <pc:spChg chg="add">
+          <ac:chgData name="Ludvig Pio" userId="9a89843c4959cd87" providerId="LiveId" clId="{874AE5E9-C85C-43CB-8B21-6910BDEE7130}" dt="2026-06-05T08:19:50.179" v="5" actId="26606"/>
+          <ac:spMkLst>
+            <pc:docMk/>
+            <pc:sldMk cId="1014079325" sldId="258"/>
+            <ac:spMk id="11" creationId="{2B97F24A-32CE-4C1C-A50D-3016B394DCFB}"/>
+          </ac:spMkLst>
+        </pc:spChg>
+        <pc:spChg chg="add">
+          <ac:chgData name="Ludvig Pio" userId="9a89843c4959cd87" providerId="LiveId" clId="{874AE5E9-C85C-43CB-8B21-6910BDEE7130}" dt="2026-06-05T08:19:50.179" v="5" actId="26606"/>
+          <ac:spMkLst>
+            <pc:docMk/>
+            <pc:sldMk cId="1014079325" sldId="258"/>
+            <ac:spMk id="13" creationId="{CD8B4F24-440B-49E9-B85D-733523DC064B}"/>
+          </ac:spMkLst>
+        </pc:spChg>
+        <pc:picChg chg="add mod">
+          <ac:chgData name="Ludvig Pio" userId="9a89843c4959cd87" providerId="LiveId" clId="{874AE5E9-C85C-43CB-8B21-6910BDEE7130}" dt="2026-06-05T08:19:50.179" v="5" actId="26606"/>
+          <ac:picMkLst>
+            <pc:docMk/>
+            <pc:sldMk cId="1014079325" sldId="258"/>
+            <ac:picMk id="4" creationId="{FD4E7253-1ABC-93BA-FDCD-FAC46A879915}"/>
+          </ac:picMkLst>
+        </pc:picChg>
+      </pc:sldChg>
+      <pc:sldChg chg="addSp delSp modSp new mod">
+        <pc:chgData name="Ludvig Pio" userId="9a89843c4959cd87" providerId="LiveId" clId="{874AE5E9-C85C-43CB-8B21-6910BDEE7130}" dt="2026-06-05T08:28:25.974" v="184" actId="1076"/>
+        <pc:sldMkLst>
+          <pc:docMk/>
+          <pc:sldMk cId="1638663160" sldId="259"/>
+        </pc:sldMkLst>
+        <pc:spChg chg="mod">
+          <ac:chgData name="Ludvig Pio" userId="9a89843c4959cd87" providerId="LiveId" clId="{874AE5E9-C85C-43CB-8B21-6910BDEE7130}" dt="2026-06-05T08:25:16.411" v="159" actId="113"/>
+          <ac:spMkLst>
+            <pc:docMk/>
+            <pc:sldMk cId="1638663160" sldId="259"/>
+            <ac:spMk id="2" creationId="{D0328152-1A49-AC12-BD11-03D15F7C05CF}"/>
+          </ac:spMkLst>
+        </pc:spChg>
+        <pc:spChg chg="del">
+          <ac:chgData name="Ludvig Pio" userId="9a89843c4959cd87" providerId="LiveId" clId="{874AE5E9-C85C-43CB-8B21-6910BDEE7130}" dt="2026-06-05T08:23:57.209" v="62"/>
+          <ac:spMkLst>
+            <pc:docMk/>
+            <pc:sldMk cId="1638663160" sldId="259"/>
+            <ac:spMk id="4" creationId="{A19AA71B-ACE2-5307-A26C-D1BCB70EEEB6}"/>
+          </ac:spMkLst>
+        </pc:spChg>
+        <pc:spChg chg="del">
+          <ac:chgData name="Ludvig Pio" userId="9a89843c4959cd87" providerId="LiveId" clId="{874AE5E9-C85C-43CB-8B21-6910BDEE7130}" dt="2026-06-05T08:23:03.157" v="48"/>
+          <ac:spMkLst>
+            <pc:docMk/>
+            <pc:sldMk cId="1638663160" sldId="259"/>
+            <ac:spMk id="6" creationId="{A4279232-7AC4-7EB1-11D8-D74B4826C882}"/>
+          </ac:spMkLst>
+        </pc:spChg>
+        <pc:spChg chg="add del mod">
+          <ac:chgData name="Ludvig Pio" userId="9a89843c4959cd87" providerId="LiveId" clId="{874AE5E9-C85C-43CB-8B21-6910BDEE7130}" dt="2026-06-05T08:28:04.482" v="177" actId="931"/>
+          <ac:spMkLst>
+            <pc:docMk/>
+            <pc:sldMk cId="1638663160" sldId="259"/>
+            <ac:spMk id="11" creationId="{683A24C0-570B-3AC2-E505-A36F4F4E1A1D}"/>
+          </ac:spMkLst>
+        </pc:spChg>
+        <pc:picChg chg="add mod">
+          <ac:chgData name="Ludvig Pio" userId="9a89843c4959cd87" providerId="LiveId" clId="{874AE5E9-C85C-43CB-8B21-6910BDEE7130}" dt="2026-06-05T08:23:42.954" v="60" actId="1076"/>
+          <ac:picMkLst>
+            <pc:docMk/>
+            <pc:sldMk cId="1638663160" sldId="259"/>
+            <ac:picMk id="7" creationId="{8384DCD9-7794-4E28-966D-006ED9A31139}"/>
+          </ac:picMkLst>
+        </pc:picChg>
+        <pc:picChg chg="add mod">
+          <ac:chgData name="Ludvig Pio" userId="9a89843c4959cd87" providerId="LiveId" clId="{874AE5E9-C85C-43CB-8B21-6910BDEE7130}" dt="2026-06-05T08:24:21.333" v="66" actId="14100"/>
+          <ac:picMkLst>
+            <pc:docMk/>
+            <pc:sldMk cId="1638663160" sldId="259"/>
+            <ac:picMk id="8" creationId="{3C17237F-6E17-6C13-408A-FB0E12CDEF48}"/>
+          </ac:picMkLst>
+        </pc:picChg>
+        <pc:picChg chg="add del mod">
+          <ac:chgData name="Ludvig Pio" userId="9a89843c4959cd87" providerId="LiveId" clId="{874AE5E9-C85C-43CB-8B21-6910BDEE7130}" dt="2026-06-05T08:27:56.439" v="176" actId="478"/>
+          <ac:picMkLst>
+            <pc:docMk/>
+            <pc:sldMk cId="1638663160" sldId="259"/>
+            <ac:picMk id="9" creationId="{9BDD5595-9B91-9F19-6533-D964FFD325B2}"/>
+          </ac:picMkLst>
+        </pc:picChg>
+        <pc:picChg chg="add mod ord">
+          <ac:chgData name="Ludvig Pio" userId="9a89843c4959cd87" providerId="LiveId" clId="{874AE5E9-C85C-43CB-8B21-6910BDEE7130}" dt="2026-06-05T08:28:25.974" v="184" actId="1076"/>
+          <ac:picMkLst>
+            <pc:docMk/>
+            <pc:sldMk cId="1638663160" sldId="259"/>
+            <ac:picMk id="13" creationId="{179F8E49-59DD-04C2-E1EB-27CC2184BBE0}"/>
+          </ac:picMkLst>
+        </pc:picChg>
+      </pc:sldChg>
+      <pc:sldChg chg="addSp delSp modSp new mod setBg">
+        <pc:chgData name="Ludvig Pio" userId="9a89843c4959cd87" providerId="LiveId" clId="{874AE5E9-C85C-43CB-8B21-6910BDEE7130}" dt="2026-06-05T08:27:14.301" v="175" actId="26606"/>
+        <pc:sldMkLst>
+          <pc:docMk/>
+          <pc:sldMk cId="3405534990" sldId="260"/>
+        </pc:sldMkLst>
+        <pc:spChg chg="mod">
+          <ac:chgData name="Ludvig Pio" userId="9a89843c4959cd87" providerId="LiveId" clId="{874AE5E9-C85C-43CB-8B21-6910BDEE7130}" dt="2026-06-05T08:27:14.301" v="175" actId="26606"/>
+          <ac:spMkLst>
+            <pc:docMk/>
+            <pc:sldMk cId="3405534990" sldId="260"/>
+            <ac:spMk id="2" creationId="{5495E4DF-11FF-A63D-A42F-C98969721ED4}"/>
+          </ac:spMkLst>
+        </pc:spChg>
+        <pc:spChg chg="del">
+          <ac:chgData name="Ludvig Pio" userId="9a89843c4959cd87" providerId="LiveId" clId="{874AE5E9-C85C-43CB-8B21-6910BDEE7130}" dt="2026-06-05T08:27:13.219" v="174" actId="931"/>
+          <ac:spMkLst>
+            <pc:docMk/>
+            <pc:sldMk cId="3405534990" sldId="260"/>
+            <ac:spMk id="3" creationId="{71B35CC1-5243-ABF8-D9CE-46209181F993}"/>
+          </ac:spMkLst>
+        </pc:spChg>
+        <pc:spChg chg="add">
+          <ac:chgData name="Ludvig Pio" userId="9a89843c4959cd87" providerId="LiveId" clId="{874AE5E9-C85C-43CB-8B21-6910BDEE7130}" dt="2026-06-05T08:27:14.301" v="175" actId="26606"/>
+          <ac:spMkLst>
+            <pc:docMk/>
+            <pc:sldMk cId="3405534990" sldId="260"/>
+            <ac:spMk id="9" creationId="{A265CE1D-EB8C-E765-1820-C5650524DA5C}"/>
+          </ac:spMkLst>
+        </pc:spChg>
+        <pc:spChg chg="add">
+          <ac:chgData name="Ludvig Pio" userId="9a89843c4959cd87" providerId="LiveId" clId="{874AE5E9-C85C-43CB-8B21-6910BDEE7130}" dt="2026-06-05T08:27:14.301" v="175" actId="26606"/>
+          <ac:spMkLst>
+            <pc:docMk/>
+            <pc:sldMk cId="3405534990" sldId="260"/>
+            <ac:spMk id="12" creationId="{2B97F24A-32CE-4C1C-A50D-3016B394DCFB}"/>
+          </ac:spMkLst>
+        </pc:spChg>
+        <pc:spChg chg="add">
+          <ac:chgData name="Ludvig Pio" userId="9a89843c4959cd87" providerId="LiveId" clId="{874AE5E9-C85C-43CB-8B21-6910BDEE7130}" dt="2026-06-05T08:27:14.301" v="175" actId="26606"/>
+          <ac:spMkLst>
+            <pc:docMk/>
+            <pc:sldMk cId="3405534990" sldId="260"/>
+            <ac:spMk id="14" creationId="{CD8B4F24-440B-49E9-B85D-733523DC064B}"/>
+          </ac:spMkLst>
+        </pc:spChg>
+        <pc:picChg chg="add mod ord">
+          <ac:chgData name="Ludvig Pio" userId="9a89843c4959cd87" providerId="LiveId" clId="{874AE5E9-C85C-43CB-8B21-6910BDEE7130}" dt="2026-06-05T08:27:14.301" v="175" actId="26606"/>
+          <ac:picMkLst>
+            <pc:docMk/>
+            <pc:sldMk cId="3405534990" sldId="260"/>
+            <ac:picMk id="5" creationId="{C6D04365-7EBD-F564-6FD6-C8D4D333919E}"/>
+          </ac:picMkLst>
+        </pc:picChg>
+      </pc:sldChg>
+      <pc:sldChg chg="addSp delSp modSp new del mod">
+        <pc:chgData name="Ludvig Pio" userId="9a89843c4959cd87" providerId="LiveId" clId="{874AE5E9-C85C-43CB-8B21-6910BDEE7130}" dt="2026-06-05T08:43:36.151" v="234" actId="47"/>
+        <pc:sldMkLst>
+          <pc:docMk/>
+          <pc:sldMk cId="3117021391" sldId="261"/>
+        </pc:sldMkLst>
+        <pc:spChg chg="mod">
+          <ac:chgData name="Ludvig Pio" userId="9a89843c4959cd87" providerId="LiveId" clId="{874AE5E9-C85C-43CB-8B21-6910BDEE7130}" dt="2026-06-05T08:35:33.775" v="201" actId="20577"/>
+          <ac:spMkLst>
+            <pc:docMk/>
+            <pc:sldMk cId="3117021391" sldId="261"/>
+            <ac:spMk id="2" creationId="{4DAAAE3D-C333-F26B-7788-408BDA29C985}"/>
+          </ac:spMkLst>
+        </pc:spChg>
+        <pc:spChg chg="del">
+          <ac:chgData name="Ludvig Pio" userId="9a89843c4959cd87" providerId="LiveId" clId="{874AE5E9-C85C-43CB-8B21-6910BDEE7130}" dt="2026-06-05T08:34:23.146" v="188" actId="931"/>
+          <ac:spMkLst>
+            <pc:docMk/>
+            <pc:sldMk cId="3117021391" sldId="261"/>
+            <ac:spMk id="3" creationId="{FBC55FA0-83BC-390C-BBD3-5E1F579FE829}"/>
+          </ac:spMkLst>
+        </pc:spChg>
+        <pc:picChg chg="add mod ord">
+          <ac:chgData name="Ludvig Pio" userId="9a89843c4959cd87" providerId="LiveId" clId="{874AE5E9-C85C-43CB-8B21-6910BDEE7130}" dt="2026-06-05T08:36:19.143" v="207" actId="14100"/>
+          <ac:picMkLst>
+            <pc:docMk/>
+            <pc:sldMk cId="3117021391" sldId="261"/>
+            <ac:picMk id="5" creationId="{F123F7D7-E3C6-FA7A-A6DE-B33FA653B842}"/>
+          </ac:picMkLst>
+        </pc:picChg>
+      </pc:sldChg>
+      <pc:sldChg chg="addSp delSp modSp new mod">
+        <pc:chgData name="Ludvig Pio" userId="9a89843c4959cd87" providerId="LiveId" clId="{874AE5E9-C85C-43CB-8B21-6910BDEE7130}" dt="2026-06-05T08:43:14.035" v="233" actId="1076"/>
+        <pc:sldMkLst>
+          <pc:docMk/>
+          <pc:sldMk cId="1456906841" sldId="262"/>
+        </pc:sldMkLst>
+        <pc:spChg chg="mod">
+          <ac:chgData name="Ludvig Pio" userId="9a89843c4959cd87" providerId="LiveId" clId="{874AE5E9-C85C-43CB-8B21-6910BDEE7130}" dt="2026-06-05T08:37:55.569" v="217"/>
+          <ac:spMkLst>
+            <pc:docMk/>
+            <pc:sldMk cId="1456906841" sldId="262"/>
+            <ac:spMk id="2" creationId="{29DB62E1-B903-A8E8-D154-479C2D897FF7}"/>
+          </ac:spMkLst>
+        </pc:spChg>
+        <pc:spChg chg="del">
+          <ac:chgData name="Ludvig Pio" userId="9a89843c4959cd87" providerId="LiveId" clId="{874AE5E9-C85C-43CB-8B21-6910BDEE7130}" dt="2026-06-05T08:36:51.130" v="209"/>
+          <ac:spMkLst>
+            <pc:docMk/>
+            <pc:sldMk cId="1456906841" sldId="262"/>
+            <ac:spMk id="3" creationId="{15336D42-5925-2EF7-E53A-983AE445EC74}"/>
+          </ac:spMkLst>
+        </pc:spChg>
+        <pc:spChg chg="del">
+          <ac:chgData name="Ludvig Pio" userId="9a89843c4959cd87" providerId="LiveId" clId="{874AE5E9-C85C-43CB-8B21-6910BDEE7130}" dt="2026-06-05T08:37:42.104" v="213" actId="931"/>
+          <ac:spMkLst>
+            <pc:docMk/>
+            <pc:sldMk cId="1456906841" sldId="262"/>
+            <ac:spMk id="4" creationId="{4EC073C7-85EF-3A87-6D36-9F946A8B9BEF}"/>
+          </ac:spMkLst>
+        </pc:spChg>
+        <pc:picChg chg="add mod">
+          <ac:chgData name="Ludvig Pio" userId="9a89843c4959cd87" providerId="LiveId" clId="{874AE5E9-C85C-43CB-8B21-6910BDEE7130}" dt="2026-06-05T08:38:36.722" v="226" actId="14100"/>
+          <ac:picMkLst>
+            <pc:docMk/>
+            <pc:sldMk cId="1456906841" sldId="262"/>
+            <ac:picMk id="5" creationId="{BCB66CDD-CCAB-0C17-6EC6-1FA50907B03D}"/>
+          </ac:picMkLst>
+        </pc:picChg>
+        <pc:picChg chg="add mod ord">
+          <ac:chgData name="Ludvig Pio" userId="9a89843c4959cd87" providerId="LiveId" clId="{874AE5E9-C85C-43CB-8B21-6910BDEE7130}" dt="2026-06-05T08:38:32.516" v="225" actId="14100"/>
+          <ac:picMkLst>
+            <pc:docMk/>
+            <pc:sldMk cId="1456906841" sldId="262"/>
+            <ac:picMk id="7" creationId="{4B2B17EE-2258-27BB-6A61-105D371FBE01}"/>
+          </ac:picMkLst>
+        </pc:picChg>
+        <pc:picChg chg="add mod">
+          <ac:chgData name="Ludvig Pio" userId="9a89843c4959cd87" providerId="LiveId" clId="{874AE5E9-C85C-43CB-8B21-6910BDEE7130}" dt="2026-06-05T08:43:14.035" v="233" actId="1076"/>
+          <ac:picMkLst>
+            <pc:docMk/>
+            <pc:sldMk cId="1456906841" sldId="262"/>
+            <ac:picMk id="9" creationId="{E1317429-3582-639E-6514-6F5413E08E77}"/>
+          </ac:picMkLst>
+        </pc:picChg>
+      </pc:sldChg>
+      <pc:sldChg chg="addSp delSp modSp new mod">
+        <pc:chgData name="Ludvig Pio" userId="9a89843c4959cd87" providerId="LiveId" clId="{874AE5E9-C85C-43CB-8B21-6910BDEE7130}" dt="2026-06-05T08:46:15.087" v="242" actId="1076"/>
+        <pc:sldMkLst>
+          <pc:docMk/>
+          <pc:sldMk cId="3455264546" sldId="263"/>
+        </pc:sldMkLst>
+        <pc:spChg chg="del">
+          <ac:chgData name="Ludvig Pio" userId="9a89843c4959cd87" providerId="LiveId" clId="{874AE5E9-C85C-43CB-8B21-6910BDEE7130}" dt="2026-06-05T08:45:36.369" v="236" actId="22"/>
+          <ac:spMkLst>
+            <pc:docMk/>
+            <pc:sldMk cId="3455264546" sldId="263"/>
+            <ac:spMk id="3" creationId="{4B613723-E323-B3A2-6725-B0640AA12C7B}"/>
+          </ac:spMkLst>
+        </pc:spChg>
+        <pc:picChg chg="add mod ord">
+          <ac:chgData name="Ludvig Pio" userId="9a89843c4959cd87" providerId="LiveId" clId="{874AE5E9-C85C-43CB-8B21-6910BDEE7130}" dt="2026-06-05T08:46:15.087" v="242" actId="1076"/>
+          <ac:picMkLst>
+            <pc:docMk/>
+            <pc:sldMk cId="3455264546" sldId="263"/>
+            <ac:picMk id="5" creationId="{2C8BC148-07C3-9CB7-91B1-4FA9BC6952F8}"/>
+          </ac:picMkLst>
+        </pc:picChg>
+      </pc:sldChg>
+    </pc:docChg>
+  </pc:docChgLst>
+</pc:chgInfo>
 </file>
 
 <file path=ppt/slideLayouts/slideLayout1.xml><?xml version="1.0" encoding="utf-8"?>
@@ -311,7 +693,7 @@
           <a:p>
             <a:fld id="{403CC89A-352F-4A3E-BAAE-6E623AFF9585}" type="slidenum">
               <a:rPr lang="da-DK" smtClean="0"/>
-              <a:t>‹#›</a:t>
+              <a:t>‹nr.›</a:t>
             </a:fld>
             <a:endParaRPr lang="da-DK"/>
           </a:p>
@@ -511,7 +893,7 @@
           <a:p>
             <a:fld id="{403CC89A-352F-4A3E-BAAE-6E623AFF9585}" type="slidenum">
               <a:rPr lang="da-DK" smtClean="0"/>
-              <a:t>‹#›</a:t>
+              <a:t>‹nr.›</a:t>
             </a:fld>
             <a:endParaRPr lang="da-DK"/>
           </a:p>
@@ -721,7 +1103,7 @@
           <a:p>
             <a:fld id="{403CC89A-352F-4A3E-BAAE-6E623AFF9585}" type="slidenum">
               <a:rPr lang="da-DK" smtClean="0"/>
-              <a:t>‹#›</a:t>
+              <a:t>‹nr.›</a:t>
             </a:fld>
             <a:endParaRPr lang="da-DK"/>
           </a:p>
@@ -921,7 +1303,7 @@
           <a:p>
             <a:fld id="{403CC89A-352F-4A3E-BAAE-6E623AFF9585}" type="slidenum">
               <a:rPr lang="da-DK" smtClean="0"/>
-              <a:t>‹#›</a:t>
+              <a:t>‹nr.›</a:t>
             </a:fld>
             <a:endParaRPr lang="da-DK"/>
           </a:p>
@@ -1197,7 +1579,7 @@
           <a:p>
             <a:fld id="{403CC89A-352F-4A3E-BAAE-6E623AFF9585}" type="slidenum">
               <a:rPr lang="da-DK" smtClean="0"/>
-              <a:t>‹#›</a:t>
+              <a:t>‹nr.›</a:t>
             </a:fld>
             <a:endParaRPr lang="da-DK"/>
           </a:p>
@@ -1465,7 +1847,7 @@
           <a:p>
             <a:fld id="{403CC89A-352F-4A3E-BAAE-6E623AFF9585}" type="slidenum">
               <a:rPr lang="da-DK" smtClean="0"/>
-              <a:t>‹#›</a:t>
+              <a:t>‹nr.›</a:t>
             </a:fld>
             <a:endParaRPr lang="da-DK"/>
           </a:p>
@@ -1880,7 +2262,7 @@
           <a:p>
             <a:fld id="{403CC89A-352F-4A3E-BAAE-6E623AFF9585}" type="slidenum">
               <a:rPr lang="da-DK" smtClean="0"/>
-              <a:t>‹#›</a:t>
+              <a:t>‹nr.›</a:t>
             </a:fld>
             <a:endParaRPr lang="da-DK"/>
           </a:p>
@@ -2022,7 +2404,7 @@
           <a:p>
             <a:fld id="{403CC89A-352F-4A3E-BAAE-6E623AFF9585}" type="slidenum">
               <a:rPr lang="da-DK" smtClean="0"/>
-              <a:t>‹#›</a:t>
+              <a:t>‹nr.›</a:t>
             </a:fld>
             <a:endParaRPr lang="da-DK"/>
           </a:p>
@@ -2135,7 +2517,7 @@
           <a:p>
             <a:fld id="{403CC89A-352F-4A3E-BAAE-6E623AFF9585}" type="slidenum">
               <a:rPr lang="da-DK" smtClean="0"/>
-              <a:t>‹#›</a:t>
+              <a:t>‹nr.›</a:t>
             </a:fld>
             <a:endParaRPr lang="da-DK"/>
           </a:p>
@@ -2448,7 +2830,7 @@
           <a:p>
             <a:fld id="{403CC89A-352F-4A3E-BAAE-6E623AFF9585}" type="slidenum">
               <a:rPr lang="da-DK" smtClean="0"/>
-              <a:t>‹#›</a:t>
+              <a:t>‹nr.›</a:t>
             </a:fld>
             <a:endParaRPr lang="da-DK"/>
           </a:p>
@@ -2737,7 +3119,7 @@
           <a:p>
             <a:fld id="{403CC89A-352F-4A3E-BAAE-6E623AFF9585}" type="slidenum">
               <a:rPr lang="da-DK" smtClean="0"/>
-              <a:t>‹#›</a:t>
+              <a:t>‹nr.›</a:t>
             </a:fld>
             <a:endParaRPr lang="da-DK"/>
           </a:p>
@@ -3016,7 +3398,7 @@
           <a:p>
             <a:fld id="{403CC89A-352F-4A3E-BAAE-6E623AFF9585}" type="slidenum">
               <a:rPr lang="da-DK" smtClean="0"/>
-              <a:t>‹#›</a:t>
+              <a:t>‹nr.›</a:t>
             </a:fld>
             <a:endParaRPr lang="da-DK"/>
           </a:p>
@@ -3359,12 +3741,44 @@
             <p:ph type="ctrTitle"/>
           </p:nvPr>
         </p:nvSpPr>
-        <p:spPr/>
-        <p:txBody>
-          <a:bodyPr/>
-          <a:lstStyle/>
-          <a:p>
-            <a:endParaRPr lang="da-DK" dirty="0"/>
+        <p:spPr>
+          <a:xfrm>
+            <a:off x="1524000" y="1071789"/>
+            <a:ext cx="9144000" cy="930049"/>
+          </a:xfrm>
+        </p:spPr>
+        <p:txBody>
+          <a:bodyPr/>
+          <a:lstStyle/>
+          <a:p>
+            <a:r>
+              <a:rPr lang="da-DK" b="1" dirty="0"/>
+              <a:t>Green? </a:t>
+            </a:r>
+            <a:r>
+              <a:rPr lang="da-DK" b="1" dirty="0" err="1"/>
+              <a:t>What</a:t>
+            </a:r>
+            <a:r>
+              <a:rPr lang="da-DK" b="1" dirty="0"/>
+              <a:t> do </a:t>
+            </a:r>
+            <a:r>
+              <a:rPr lang="da-DK" b="1" dirty="0" err="1"/>
+              <a:t>you</a:t>
+            </a:r>
+            <a:r>
+              <a:rPr lang="da-DK" b="1" dirty="0"/>
+              <a:t> </a:t>
+            </a:r>
+            <a:r>
+              <a:rPr lang="da-DK" b="1" dirty="0" err="1"/>
+              <a:t>mean</a:t>
+            </a:r>
+            <a:r>
+              <a:rPr lang="da-DK" b="1" dirty="0"/>
+              <a:t>?</a:t>
+            </a:r>
           </a:p>
         </p:txBody>
       </p:sp>
@@ -3384,15 +3798,16 @@
             <p:ph type="subTitle" idx="1"/>
           </p:nvPr>
         </p:nvSpPr>
-        <p:spPr/>
-        <p:txBody>
-          <a:bodyPr/>
-          <a:lstStyle/>
-          <a:p>
-            <a:r>
-              <a:rPr lang="en-GB" dirty="0"/>
-              <a:t>Green? What do you mean?</a:t>
-            </a:r>
+        <p:spPr>
+          <a:xfrm>
+            <a:off x="1523999" y="2111375"/>
+            <a:ext cx="9144000" cy="1655762"/>
+          </a:xfrm>
+        </p:spPr>
+        <p:txBody>
+          <a:bodyPr/>
+          <a:lstStyle/>
+          <a:p>
             <a:endParaRPr lang="da-DK" dirty="0"/>
           </a:p>
         </p:txBody>
@@ -3419,38 +3834,8 @@
         </p:blipFill>
         <p:spPr>
           <a:xfrm>
-            <a:off x="0" y="0"/>
-            <a:ext cx="5172075" cy="2981325"/>
-          </a:xfrm>
-          <a:prstGeom prst="rect">
-            <a:avLst/>
-          </a:prstGeom>
-        </p:spPr>
-      </p:pic>
-      <p:pic>
-        <p:nvPicPr>
-          <p:cNvPr id="9" name="Picture 8">
-            <a:extLst>
-              <a:ext uri="{FF2B5EF4-FFF2-40B4-BE49-F238E27FC236}">
-                <a16:creationId xmlns:a16="http://schemas.microsoft.com/office/drawing/2014/main" id="{06C65975-B78E-C8AE-82EE-D71DAA1BC71E}"/>
-              </a:ext>
-            </a:extLst>
-          </p:cNvPr>
-          <p:cNvPicPr>
-            <a:picLocks noChangeAspect="1"/>
-          </p:cNvPicPr>
-          <p:nvPr/>
-        </p:nvPicPr>
-        <p:blipFill>
-          <a:blip r:embed="rId3"/>
-          <a:stretch>
-            <a:fillRect/>
-          </a:stretch>
-        </p:blipFill>
-        <p:spPr>
-          <a:xfrm>
-            <a:off x="5250271" y="109537"/>
-            <a:ext cx="5172075" cy="2981325"/>
+            <a:off x="2156947" y="2001838"/>
+            <a:ext cx="7688079" cy="4431619"/>
           </a:xfrm>
           <a:prstGeom prst="rect">
             <a:avLst/>
@@ -3489,18 +3874,18 @@
       </p:grpSpPr>
       <p:sp>
         <p:nvSpPr>
-          <p:cNvPr id="2" name="Title 1">
-            <a:extLst>
-              <a:ext uri="{FF2B5EF4-FFF2-40B4-BE49-F238E27FC236}">
-                <a16:creationId xmlns:a16="http://schemas.microsoft.com/office/drawing/2014/main" id="{41836487-F5ED-7E70-0E34-B315086DE760}"/>
-              </a:ext>
-            </a:extLst>
-          </p:cNvPr>
-          <p:cNvSpPr>
-            <a:spLocks noGrp="1"/>
-          </p:cNvSpPr>
-          <p:nvPr>
-            <p:ph type="ctrTitle"/>
+          <p:cNvPr id="2" name="Titel 1">
+            <a:extLst>
+              <a:ext uri="{FF2B5EF4-FFF2-40B4-BE49-F238E27FC236}">
+                <a16:creationId xmlns:a16="http://schemas.microsoft.com/office/drawing/2014/main" id="{D0328152-1A49-AC12-BD11-03D15F7C05CF}"/>
+              </a:ext>
+            </a:extLst>
+          </p:cNvPr>
+          <p:cNvSpPr>
+            <a:spLocks noGrp="1"/>
+          </p:cNvSpPr>
+          <p:nvPr>
+            <p:ph type="title"/>
           </p:nvPr>
         </p:nvSpPr>
         <p:spPr/>
@@ -3508,24 +3893,43 @@
           <a:bodyPr/>
           <a:lstStyle/>
           <a:p>
-            <a:endParaRPr lang="da-DK"/>
-          </a:p>
-        </p:txBody>
-      </p:sp>
-      <p:sp>
-        <p:nvSpPr>
-          <p:cNvPr id="3" name="Subtitle 2">
-            <a:extLst>
-              <a:ext uri="{FF2B5EF4-FFF2-40B4-BE49-F238E27FC236}">
-                <a16:creationId xmlns:a16="http://schemas.microsoft.com/office/drawing/2014/main" id="{694927D8-915E-F206-CA3F-C82ED210E223}"/>
-              </a:ext>
-            </a:extLst>
-          </p:cNvPr>
-          <p:cNvSpPr>
-            <a:spLocks noGrp="1"/>
-          </p:cNvSpPr>
-          <p:nvPr>
-            <p:ph type="subTitle" idx="1"/>
+            <a:r>
+              <a:rPr lang="da-DK" b="1" dirty="0"/>
+              <a:t>VAE </a:t>
+            </a:r>
+            <a:r>
+              <a:rPr lang="da-DK" b="1" dirty="0" err="1"/>
+              <a:t>results</a:t>
+            </a:r>
+            <a:r>
+              <a:rPr lang="da-DK" b="1" dirty="0"/>
+              <a:t> with </a:t>
+            </a:r>
+            <a:r>
+              <a:rPr lang="da-DK" b="1" dirty="0" err="1"/>
+              <a:t>padded</a:t>
+            </a:r>
+            <a:r>
+              <a:rPr lang="da-DK" b="1" dirty="0"/>
+              <a:t> images</a:t>
+            </a:r>
+          </a:p>
+        </p:txBody>
+      </p:sp>
+      <p:sp>
+        <p:nvSpPr>
+          <p:cNvPr id="3" name="Pladsholder til tekst 2">
+            <a:extLst>
+              <a:ext uri="{FF2B5EF4-FFF2-40B4-BE49-F238E27FC236}">
+                <a16:creationId xmlns:a16="http://schemas.microsoft.com/office/drawing/2014/main" id="{D00F19EB-0D0B-3F80-DD13-FD88BB03FF44}"/>
+              </a:ext>
+            </a:extLst>
+          </p:cNvPr>
+          <p:cNvSpPr>
+            <a:spLocks noGrp="1"/>
+          </p:cNvSpPr>
+          <p:nvPr>
+            <p:ph type="body" idx="1"/>
           </p:nvPr>
         </p:nvSpPr>
         <p:spPr/>
@@ -3533,23 +3937,50 @@
           <a:bodyPr/>
           <a:lstStyle/>
           <a:p>
-            <a:endParaRPr lang="da-DK"/>
+            <a:endParaRPr lang="da-DK" dirty="0"/>
+          </a:p>
+        </p:txBody>
+      </p:sp>
+      <p:sp>
+        <p:nvSpPr>
+          <p:cNvPr id="5" name="Pladsholder til tekst 4">
+            <a:extLst>
+              <a:ext uri="{FF2B5EF4-FFF2-40B4-BE49-F238E27FC236}">
+                <a16:creationId xmlns:a16="http://schemas.microsoft.com/office/drawing/2014/main" id="{E39266E0-D729-EA35-84AE-29B159611D0A}"/>
+              </a:ext>
+            </a:extLst>
+          </p:cNvPr>
+          <p:cNvSpPr>
+            <a:spLocks noGrp="1"/>
+          </p:cNvSpPr>
+          <p:nvPr>
+            <p:ph type="body" sz="quarter" idx="3"/>
+          </p:nvPr>
+        </p:nvSpPr>
+        <p:spPr/>
+        <p:txBody>
+          <a:bodyPr/>
+          <a:lstStyle/>
+          <a:p>
+            <a:endParaRPr lang="da-DK" dirty="0"/>
           </a:p>
         </p:txBody>
       </p:sp>
       <p:pic>
         <p:nvPicPr>
-          <p:cNvPr id="4" name="Picture 3">
-            <a:extLst>
-              <a:ext uri="{FF2B5EF4-FFF2-40B4-BE49-F238E27FC236}">
-                <a16:creationId xmlns:a16="http://schemas.microsoft.com/office/drawing/2014/main" id="{81DA7B68-43E1-5A0B-0EF4-DA66C78A7966}"/>
+          <p:cNvPr id="7" name="Picture 6">
+            <a:extLst>
+              <a:ext uri="{FF2B5EF4-FFF2-40B4-BE49-F238E27FC236}">
+                <a16:creationId xmlns:a16="http://schemas.microsoft.com/office/drawing/2014/main" id="{8384DCD9-7794-4E28-966D-006ED9A31139}"/>
               </a:ext>
             </a:extLst>
           </p:cNvPr>
           <p:cNvPicPr>
-            <a:picLocks noChangeAspect="1"/>
+            <a:picLocks noGrp="1" noChangeAspect="1"/>
           </p:cNvPicPr>
-          <p:nvPr/>
+          <p:nvPr>
+            <p:ph sz="quarter" idx="4"/>
+          </p:nvPr>
         </p:nvPicPr>
         <p:blipFill>
           <a:blip r:embed="rId2"/>
@@ -3559,8 +3990,76 @@
         </p:blipFill>
         <p:spPr>
           <a:xfrm>
-            <a:off x="235188" y="781050"/>
-            <a:ext cx="5276850" cy="4476750"/>
+            <a:off x="6605814" y="4184665"/>
+            <a:ext cx="4528911" cy="2610588"/>
+          </a:xfrm>
+          <a:prstGeom prst="rect">
+            <a:avLst/>
+          </a:prstGeom>
+        </p:spPr>
+      </p:pic>
+      <p:pic>
+        <p:nvPicPr>
+          <p:cNvPr id="8" name="Picture 8">
+            <a:extLst>
+              <a:ext uri="{FF2B5EF4-FFF2-40B4-BE49-F238E27FC236}">
+                <a16:creationId xmlns:a16="http://schemas.microsoft.com/office/drawing/2014/main" id="{3C17237F-6E17-6C13-408A-FB0E12CDEF48}"/>
+              </a:ext>
+            </a:extLst>
+          </p:cNvPr>
+          <p:cNvPicPr>
+            <a:picLocks noChangeAspect="1"/>
+          </p:cNvPicPr>
+          <p:nvPr/>
+        </p:nvPicPr>
+        <p:blipFill>
+          <a:blip r:embed="rId3"/>
+          <a:stretch>
+            <a:fillRect/>
+          </a:stretch>
+        </p:blipFill>
+        <p:spPr>
+          <a:xfrm>
+            <a:off x="6651511" y="1640056"/>
+            <a:ext cx="4483214" cy="2584247"/>
+          </a:xfrm>
+          <a:prstGeom prst="rect">
+            <a:avLst/>
+          </a:prstGeom>
+        </p:spPr>
+      </p:pic>
+      <p:pic>
+        <p:nvPicPr>
+          <p:cNvPr id="13" name="Pladsholder til indhold 12">
+            <a:extLst>
+              <a:ext uri="{FF2B5EF4-FFF2-40B4-BE49-F238E27FC236}">
+                <a16:creationId xmlns:a16="http://schemas.microsoft.com/office/drawing/2014/main" id="{179F8E49-59DD-04C2-E1EB-27CC2184BBE0}"/>
+              </a:ext>
+            </a:extLst>
+          </p:cNvPr>
+          <p:cNvPicPr>
+            <a:picLocks noGrp="1" noChangeAspect="1"/>
+          </p:cNvPicPr>
+          <p:nvPr>
+            <p:ph sz="half" idx="2"/>
+          </p:nvPr>
+        </p:nvPicPr>
+        <p:blipFill>
+          <a:blip r:embed="rId4">
+            <a:extLst>
+              <a:ext uri="{28A0092B-C50C-407E-A947-70E740481C1C}">
+                <a14:useLocalDpi xmlns:a14="http://schemas.microsoft.com/office/drawing/2010/main" val="0"/>
+              </a:ext>
+            </a:extLst>
+          </a:blip>
+          <a:stretch>
+            <a:fillRect/>
+          </a:stretch>
+        </p:blipFill>
+        <p:spPr>
+          <a:xfrm>
+            <a:off x="334075" y="1854774"/>
+            <a:ext cx="5860352" cy="4739058"/>
           </a:xfrm>
           <a:prstGeom prst="rect">
             <a:avLst/>
@@ -3570,7 +4069,755 @@
     </p:spTree>
     <p:extLst>
       <p:ext uri="{BB962C8B-B14F-4D97-AF65-F5344CB8AC3E}">
-        <p14:creationId xmlns:p14="http://schemas.microsoft.com/office/powerpoint/2010/main" val="549751496"/>
+        <p14:creationId xmlns:p14="http://schemas.microsoft.com/office/powerpoint/2010/main" val="1638663160"/>
+      </p:ext>
+    </p:extLst>
+  </p:cSld>
+  <p:clrMapOvr>
+    <a:masterClrMapping/>
+  </p:clrMapOvr>
+</p:sld>
+</file>
+
+<file path=ppt/slides/slide3.xml><?xml version="1.0" encoding="utf-8"?>
+<p:sld xmlns:a="http://schemas.openxmlformats.org/drawingml/2006/main" xmlns:r="http://schemas.openxmlformats.org/officeDocument/2006/relationships" xmlns:p="http://schemas.openxmlformats.org/presentationml/2006/main">
+  <p:cSld>
+    <p:spTree>
+      <p:nvGrpSpPr>
+        <p:cNvPr id="1" name=""/>
+        <p:cNvGrpSpPr/>
+        <p:nvPr/>
+      </p:nvGrpSpPr>
+      <p:grpSpPr>
+        <a:xfrm>
+          <a:off x="0" y="0"/>
+          <a:ext cx="0" cy="0"/>
+          <a:chOff x="0" y="0"/>
+          <a:chExt cx="0" cy="0"/>
+        </a:xfrm>
+      </p:grpSpPr>
+      <p:sp>
+        <p:nvSpPr>
+          <p:cNvPr id="2" name="Titel 1">
+            <a:extLst>
+              <a:ext uri="{FF2B5EF4-FFF2-40B4-BE49-F238E27FC236}">
+                <a16:creationId xmlns:a16="http://schemas.microsoft.com/office/drawing/2014/main" id="{29DB62E1-B903-A8E8-D154-479C2D897FF7}"/>
+              </a:ext>
+            </a:extLst>
+          </p:cNvPr>
+          <p:cNvSpPr>
+            <a:spLocks noGrp="1"/>
+          </p:cNvSpPr>
+          <p:nvPr>
+            <p:ph type="title"/>
+          </p:nvPr>
+        </p:nvSpPr>
+        <p:spPr/>
+        <p:txBody>
+          <a:bodyPr/>
+          <a:lstStyle/>
+          <a:p>
+            <a:r>
+              <a:rPr lang="da-DK" b="1" dirty="0"/>
+              <a:t>VAE with </a:t>
+            </a:r>
+            <a:r>
+              <a:rPr lang="da-DK" b="1" dirty="0" err="1"/>
+              <a:t>correctly</a:t>
+            </a:r>
+            <a:r>
+              <a:rPr lang="da-DK" b="1" dirty="0"/>
+              <a:t> </a:t>
+            </a:r>
+            <a:r>
+              <a:rPr lang="da-DK" b="1" dirty="0" err="1"/>
+              <a:t>sized</a:t>
+            </a:r>
+            <a:r>
+              <a:rPr lang="da-DK" b="1" dirty="0"/>
+              <a:t> images</a:t>
+            </a:r>
+            <a:endParaRPr lang="da-DK" dirty="0"/>
+          </a:p>
+        </p:txBody>
+      </p:sp>
+      <p:pic>
+        <p:nvPicPr>
+          <p:cNvPr id="7" name="Pladsholder til indhold 6">
+            <a:extLst>
+              <a:ext uri="{FF2B5EF4-FFF2-40B4-BE49-F238E27FC236}">
+                <a16:creationId xmlns:a16="http://schemas.microsoft.com/office/drawing/2014/main" id="{4B2B17EE-2258-27BB-6A61-105D371FBE01}"/>
+              </a:ext>
+            </a:extLst>
+          </p:cNvPr>
+          <p:cNvPicPr>
+            <a:picLocks noGrp="1" noChangeAspect="1"/>
+          </p:cNvPicPr>
+          <p:nvPr>
+            <p:ph sz="half" idx="2"/>
+          </p:nvPr>
+        </p:nvPicPr>
+        <p:blipFill>
+          <a:blip r:embed="rId2">
+            <a:extLst>
+              <a:ext uri="{28A0092B-C50C-407E-A947-70E740481C1C}">
+                <a14:useLocalDpi xmlns:a14="http://schemas.microsoft.com/office/drawing/2010/main" val="0"/>
+              </a:ext>
+            </a:extLst>
+          </a:blip>
+          <a:stretch>
+            <a:fillRect/>
+          </a:stretch>
+        </p:blipFill>
+        <p:spPr>
+          <a:xfrm>
+            <a:off x="6564086" y="3960553"/>
+            <a:ext cx="4789714" cy="2760922"/>
+          </a:xfrm>
+          <a:prstGeom prst="rect">
+            <a:avLst/>
+          </a:prstGeom>
+        </p:spPr>
+      </p:pic>
+      <p:pic>
+        <p:nvPicPr>
+          <p:cNvPr id="5" name="Pladsholder til indhold 4">
+            <a:extLst>
+              <a:ext uri="{FF2B5EF4-FFF2-40B4-BE49-F238E27FC236}">
+                <a16:creationId xmlns:a16="http://schemas.microsoft.com/office/drawing/2014/main" id="{BCB66CDD-CCAB-0C17-6EC6-1FA50907B03D}"/>
+              </a:ext>
+            </a:extLst>
+          </p:cNvPr>
+          <p:cNvPicPr>
+            <a:picLocks noGrp="1" noChangeAspect="1"/>
+          </p:cNvPicPr>
+          <p:nvPr>
+            <p:ph sz="half" idx="1"/>
+          </p:nvPr>
+        </p:nvPicPr>
+        <p:blipFill>
+          <a:blip r:embed="rId3">
+            <a:extLst>
+              <a:ext uri="{28A0092B-C50C-407E-A947-70E740481C1C}">
+                <a14:useLocalDpi xmlns:a14="http://schemas.microsoft.com/office/drawing/2010/main" val="0"/>
+              </a:ext>
+            </a:extLst>
+          </a:blip>
+          <a:stretch>
+            <a:fillRect/>
+          </a:stretch>
+        </p:blipFill>
+        <p:spPr>
+          <a:xfrm>
+            <a:off x="6564086" y="1726137"/>
+            <a:ext cx="5019970" cy="2133260"/>
+          </a:xfrm>
+          <a:prstGeom prst="rect">
+            <a:avLst/>
+          </a:prstGeom>
+        </p:spPr>
+      </p:pic>
+      <p:pic>
+        <p:nvPicPr>
+          <p:cNvPr id="9" name="Billede 8">
+            <a:extLst>
+              <a:ext uri="{FF2B5EF4-FFF2-40B4-BE49-F238E27FC236}">
+                <a16:creationId xmlns:a16="http://schemas.microsoft.com/office/drawing/2014/main" id="{E1317429-3582-639E-6514-6F5413E08E77}"/>
+              </a:ext>
+            </a:extLst>
+          </p:cNvPr>
+          <p:cNvPicPr>
+            <a:picLocks noChangeAspect="1"/>
+          </p:cNvPicPr>
+          <p:nvPr/>
+        </p:nvPicPr>
+        <p:blipFill>
+          <a:blip r:embed="rId4">
+            <a:extLst>
+              <a:ext uri="{28A0092B-C50C-407E-A947-70E740481C1C}">
+                <a14:useLocalDpi xmlns:a14="http://schemas.microsoft.com/office/drawing/2010/main" val="0"/>
+              </a:ext>
+            </a:extLst>
+          </a:blip>
+          <a:stretch>
+            <a:fillRect/>
+          </a:stretch>
+        </p:blipFill>
+        <p:spPr>
+          <a:xfrm>
+            <a:off x="335801" y="1802337"/>
+            <a:ext cx="6080030" cy="4560023"/>
+          </a:xfrm>
+          <a:prstGeom prst="rect">
+            <a:avLst/>
+          </a:prstGeom>
+        </p:spPr>
+      </p:pic>
+    </p:spTree>
+    <p:extLst>
+      <p:ext uri="{BB962C8B-B14F-4D97-AF65-F5344CB8AC3E}">
+        <p14:creationId xmlns:p14="http://schemas.microsoft.com/office/powerpoint/2010/main" val="1456906841"/>
+      </p:ext>
+    </p:extLst>
+  </p:cSld>
+  <p:clrMapOvr>
+    <a:masterClrMapping/>
+  </p:clrMapOvr>
+</p:sld>
+</file>
+
+<file path=ppt/slides/slide4.xml><?xml version="1.0" encoding="utf-8"?>
+<p:sld xmlns:a="http://schemas.openxmlformats.org/drawingml/2006/main" xmlns:r="http://schemas.openxmlformats.org/officeDocument/2006/relationships" xmlns:p="http://schemas.openxmlformats.org/presentationml/2006/main">
+  <p:cSld>
+    <p:bg>
+      <p:bgPr>
+        <a:solidFill>
+          <a:schemeClr val="bg1"/>
+        </a:solidFill>
+        <a:effectLst/>
+      </p:bgPr>
+    </p:bg>
+    <p:spTree>
+      <p:nvGrpSpPr>
+        <p:cNvPr id="1" name=""/>
+        <p:cNvGrpSpPr/>
+        <p:nvPr/>
+      </p:nvGrpSpPr>
+      <p:grpSpPr>
+        <a:xfrm>
+          <a:off x="0" y="0"/>
+          <a:ext cx="0" cy="0"/>
+          <a:chOff x="0" y="0"/>
+          <a:chExt cx="0" cy="0"/>
+        </a:xfrm>
+      </p:grpSpPr>
+      <p:sp useBgFill="1">
+        <p:nvSpPr>
+          <p:cNvPr id="12" name="Rectangle 11">
+            <a:extLst>
+              <a:ext uri="{FF2B5EF4-FFF2-40B4-BE49-F238E27FC236}">
+                <a16:creationId xmlns:a16="http://schemas.microsoft.com/office/drawing/2014/main" id="{2B97F24A-32CE-4C1C-A50D-3016B394DCFB}"/>
+              </a:ext>
+              <a:ext uri="{C183D7F6-B498-43B3-948B-1728B52AA6E4}">
+                <adec:decorative xmlns:adec="http://schemas.microsoft.com/office/drawing/2017/decorative" val="1"/>
+              </a:ext>
+            </a:extLst>
+          </p:cNvPr>
+          <p:cNvSpPr>
+            <a:spLocks noGrp="1" noRot="1" noChangeAspect="1" noMove="1" noResize="1" noEditPoints="1" noAdjustHandles="1" noChangeArrowheads="1" noChangeShapeType="1" noTextEdit="1"/>
+          </p:cNvSpPr>
+          <p:nvPr>
+            <p:extLst>
+              <p:ext uri="{386F3935-93C4-4BCD-93E2-E3B085C9AB24}">
+                <p16:designElem xmlns:p16="http://schemas.microsoft.com/office/powerpoint/2015/main" val="1"/>
+              </p:ext>
+            </p:extLst>
+          </p:nvPr>
+        </p:nvSpPr>
+        <p:spPr>
+          <a:xfrm>
+            <a:off x="0" y="0"/>
+            <a:ext cx="12192000" cy="6858000"/>
+          </a:xfrm>
+          <a:prstGeom prst="rect">
+            <a:avLst/>
+          </a:prstGeom>
+          <a:ln>
+            <a:noFill/>
+          </a:ln>
+        </p:spPr>
+        <p:style>
+          <a:lnRef idx="2">
+            <a:schemeClr val="accent1">
+              <a:shade val="50000"/>
+            </a:schemeClr>
+          </a:lnRef>
+          <a:fillRef idx="1">
+            <a:schemeClr val="accent1"/>
+          </a:fillRef>
+          <a:effectRef idx="0">
+            <a:schemeClr val="accent1"/>
+          </a:effectRef>
+          <a:fontRef idx="minor">
+            <a:schemeClr val="lt1"/>
+          </a:fontRef>
+        </p:style>
+        <p:txBody>
+          <a:bodyPr rtlCol="0" anchor="ctr"/>
+          <a:lstStyle/>
+          <a:p>
+            <a:pPr algn="ctr"/>
+            <a:endParaRPr lang="en-US"/>
+          </a:p>
+        </p:txBody>
+      </p:sp>
+      <p:sp>
+        <p:nvSpPr>
+          <p:cNvPr id="2" name="Titel 1">
+            <a:extLst>
+              <a:ext uri="{FF2B5EF4-FFF2-40B4-BE49-F238E27FC236}">
+                <a16:creationId xmlns:a16="http://schemas.microsoft.com/office/drawing/2014/main" id="{5495E4DF-11FF-A63D-A42F-C98969721ED4}"/>
+              </a:ext>
+            </a:extLst>
+          </p:cNvPr>
+          <p:cNvSpPr>
+            <a:spLocks noGrp="1"/>
+          </p:cNvSpPr>
+          <p:nvPr>
+            <p:ph type="title"/>
+          </p:nvPr>
+        </p:nvSpPr>
+        <p:spPr>
+          <a:xfrm>
+            <a:off x="630936" y="639520"/>
+            <a:ext cx="3429000" cy="1719072"/>
+          </a:xfrm>
+        </p:spPr>
+        <p:txBody>
+          <a:bodyPr anchor="b">
+            <a:normAutofit/>
+          </a:bodyPr>
+          <a:lstStyle/>
+          <a:p>
+            <a:r>
+              <a:rPr lang="da-DK" sz="5400" b="1"/>
+              <a:t>Appendix</a:t>
+            </a:r>
+          </a:p>
+        </p:txBody>
+      </p:sp>
+      <p:sp>
+        <p:nvSpPr>
+          <p:cNvPr id="14" name="sketch line">
+            <a:extLst>
+              <a:ext uri="{FF2B5EF4-FFF2-40B4-BE49-F238E27FC236}">
+                <a16:creationId xmlns:a16="http://schemas.microsoft.com/office/drawing/2014/main" id="{CD8B4F24-440B-49E9-B85D-733523DC064B}"/>
+              </a:ext>
+              <a:ext uri="{C183D7F6-B498-43B3-948B-1728B52AA6E4}">
+                <adec:decorative xmlns:adec="http://schemas.microsoft.com/office/drawing/2017/decorative" val="1"/>
+              </a:ext>
+            </a:extLst>
+          </p:cNvPr>
+          <p:cNvSpPr>
+            <a:spLocks noGrp="1" noRot="1" noChangeAspect="1" noMove="1" noResize="1" noEditPoints="1" noAdjustHandles="1" noChangeArrowheads="1" noChangeShapeType="1" noTextEdit="1"/>
+          </p:cNvSpPr>
+          <p:nvPr>
+            <p:extLst>
+              <p:ext uri="{386F3935-93C4-4BCD-93E2-E3B085C9AB24}">
+                <p16:designElem xmlns:p16="http://schemas.microsoft.com/office/powerpoint/2015/main" val="1"/>
+              </p:ext>
+            </p:extLst>
+          </p:nvPr>
+        </p:nvSpPr>
+        <p:spPr>
+          <a:xfrm>
+            <a:off x="643278" y="2573756"/>
+            <a:ext cx="3255095" cy="18288"/>
+          </a:xfrm>
+          <a:custGeom>
+            <a:avLst/>
+            <a:gdLst>
+              <a:gd name="csX0" fmla="*/ 0 w 3255095"/>
+              <a:gd name="csY0" fmla="*/ 0 h 18288"/>
+              <a:gd name="csX1" fmla="*/ 618468 w 3255095"/>
+              <a:gd name="csY1" fmla="*/ 0 h 18288"/>
+              <a:gd name="csX2" fmla="*/ 1269487 w 3255095"/>
+              <a:gd name="csY2" fmla="*/ 0 h 18288"/>
+              <a:gd name="csX3" fmla="*/ 1953057 w 3255095"/>
+              <a:gd name="csY3" fmla="*/ 0 h 18288"/>
+              <a:gd name="csX4" fmla="*/ 2636627 w 3255095"/>
+              <a:gd name="csY4" fmla="*/ 0 h 18288"/>
+              <a:gd name="csX5" fmla="*/ 3255095 w 3255095"/>
+              <a:gd name="csY5" fmla="*/ 0 h 18288"/>
+              <a:gd name="csX6" fmla="*/ 3255095 w 3255095"/>
+              <a:gd name="csY6" fmla="*/ 18288 h 18288"/>
+              <a:gd name="csX7" fmla="*/ 2538974 w 3255095"/>
+              <a:gd name="csY7" fmla="*/ 18288 h 18288"/>
+              <a:gd name="csX8" fmla="*/ 1822853 w 3255095"/>
+              <a:gd name="csY8" fmla="*/ 18288 h 18288"/>
+              <a:gd name="csX9" fmla="*/ 1171834 w 3255095"/>
+              <a:gd name="csY9" fmla="*/ 18288 h 18288"/>
+              <a:gd name="csX10" fmla="*/ 0 w 3255095"/>
+              <a:gd name="csY10" fmla="*/ 18288 h 18288"/>
+              <a:gd name="csX11" fmla="*/ 0 w 3255095"/>
+              <a:gd name="csY11" fmla="*/ 0 h 18288"/>
+            </a:gdLst>
+            <a:ahLst/>
+            <a:cxnLst>
+              <a:cxn ang="0">
+                <a:pos x="csX0" y="csY0"/>
+              </a:cxn>
+              <a:cxn ang="0">
+                <a:pos x="csX1" y="csY1"/>
+              </a:cxn>
+              <a:cxn ang="0">
+                <a:pos x="csX2" y="csY2"/>
+              </a:cxn>
+              <a:cxn ang="0">
+                <a:pos x="csX3" y="csY3"/>
+              </a:cxn>
+              <a:cxn ang="0">
+                <a:pos x="csX4" y="csY4"/>
+              </a:cxn>
+              <a:cxn ang="0">
+                <a:pos x="csX5" y="csY5"/>
+              </a:cxn>
+              <a:cxn ang="0">
+                <a:pos x="csX6" y="csY6"/>
+              </a:cxn>
+              <a:cxn ang="0">
+                <a:pos x="csX7" y="csY7"/>
+              </a:cxn>
+              <a:cxn ang="0">
+                <a:pos x="csX8" y="csY8"/>
+              </a:cxn>
+              <a:cxn ang="0">
+                <a:pos x="csX9" y="csY9"/>
+              </a:cxn>
+              <a:cxn ang="0">
+                <a:pos x="csX10" y="csY10"/>
+              </a:cxn>
+              <a:cxn ang="0">
+                <a:pos x="csX11" y="csY11"/>
+              </a:cxn>
+            </a:cxnLst>
+            <a:rect l="l" t="t" r="r" b="b"/>
+            <a:pathLst>
+              <a:path w="3255095" h="18288" fill="none" extrusionOk="0">
+                <a:moveTo>
+                  <a:pt x="0" y="0"/>
+                </a:moveTo>
+                <a:cubicBezTo>
+                  <a:pt x="240201" y="-22123"/>
+                  <a:pt x="462021" y="-19623"/>
+                  <a:pt x="618468" y="0"/>
+                </a:cubicBezTo>
+                <a:cubicBezTo>
+                  <a:pt x="774915" y="19623"/>
+                  <a:pt x="974734" y="2035"/>
+                  <a:pt x="1269487" y="0"/>
+                </a:cubicBezTo>
+                <a:cubicBezTo>
+                  <a:pt x="1564240" y="-2035"/>
+                  <a:pt x="1733579" y="10639"/>
+                  <a:pt x="1953057" y="0"/>
+                </a:cubicBezTo>
+                <a:cubicBezTo>
+                  <a:pt x="2172535" y="-10639"/>
+                  <a:pt x="2453962" y="14018"/>
+                  <a:pt x="2636627" y="0"/>
+                </a:cubicBezTo>
+                <a:cubicBezTo>
+                  <a:pt x="2819292" y="-14018"/>
+                  <a:pt x="3121375" y="5399"/>
+                  <a:pt x="3255095" y="0"/>
+                </a:cubicBezTo>
+                <a:cubicBezTo>
+                  <a:pt x="3254386" y="8157"/>
+                  <a:pt x="3254682" y="12125"/>
+                  <a:pt x="3255095" y="18288"/>
+                </a:cubicBezTo>
+                <a:cubicBezTo>
+                  <a:pt x="3088545" y="23203"/>
+                  <a:pt x="2687475" y="7419"/>
+                  <a:pt x="2538974" y="18288"/>
+                </a:cubicBezTo>
+                <a:cubicBezTo>
+                  <a:pt x="2390473" y="29157"/>
+                  <a:pt x="2137381" y="-8959"/>
+                  <a:pt x="1822853" y="18288"/>
+                </a:cubicBezTo>
+                <a:cubicBezTo>
+                  <a:pt x="1508325" y="45535"/>
+                  <a:pt x="1466437" y="20385"/>
+                  <a:pt x="1171834" y="18288"/>
+                </a:cubicBezTo>
+                <a:cubicBezTo>
+                  <a:pt x="877231" y="16191"/>
+                  <a:pt x="561097" y="37643"/>
+                  <a:pt x="0" y="18288"/>
+                </a:cubicBezTo>
+                <a:cubicBezTo>
+                  <a:pt x="-46" y="12483"/>
+                  <a:pt x="-203" y="6491"/>
+                  <a:pt x="0" y="0"/>
+                </a:cubicBezTo>
+                <a:close/>
+              </a:path>
+              <a:path w="3255095" h="18288" stroke="0" extrusionOk="0">
+                <a:moveTo>
+                  <a:pt x="0" y="0"/>
+                </a:moveTo>
+                <a:cubicBezTo>
+                  <a:pt x="291965" y="19429"/>
+                  <a:pt x="363155" y="8568"/>
+                  <a:pt x="618468" y="0"/>
+                </a:cubicBezTo>
+                <a:cubicBezTo>
+                  <a:pt x="873781" y="-8568"/>
+                  <a:pt x="904459" y="-19505"/>
+                  <a:pt x="1171834" y="0"/>
+                </a:cubicBezTo>
+                <a:cubicBezTo>
+                  <a:pt x="1439209" y="19505"/>
+                  <a:pt x="1744369" y="9790"/>
+                  <a:pt x="1887955" y="0"/>
+                </a:cubicBezTo>
+                <a:cubicBezTo>
+                  <a:pt x="2031541" y="-9790"/>
+                  <a:pt x="2346378" y="21240"/>
+                  <a:pt x="2506423" y="0"/>
+                </a:cubicBezTo>
+                <a:cubicBezTo>
+                  <a:pt x="2666468" y="-21240"/>
+                  <a:pt x="2990257" y="30414"/>
+                  <a:pt x="3255095" y="0"/>
+                </a:cubicBezTo>
+                <a:cubicBezTo>
+                  <a:pt x="3254831" y="4493"/>
+                  <a:pt x="3255479" y="9472"/>
+                  <a:pt x="3255095" y="18288"/>
+                </a:cubicBezTo>
+                <a:cubicBezTo>
+                  <a:pt x="3120743" y="16690"/>
+                  <a:pt x="2759628" y="42462"/>
+                  <a:pt x="2604076" y="18288"/>
+                </a:cubicBezTo>
+                <a:cubicBezTo>
+                  <a:pt x="2448524" y="-5886"/>
+                  <a:pt x="2184336" y="19599"/>
+                  <a:pt x="1887955" y="18288"/>
+                </a:cubicBezTo>
+                <a:cubicBezTo>
+                  <a:pt x="1591574" y="16977"/>
+                  <a:pt x="1548845" y="6870"/>
+                  <a:pt x="1334589" y="18288"/>
+                </a:cubicBezTo>
+                <a:cubicBezTo>
+                  <a:pt x="1120333" y="29706"/>
+                  <a:pt x="996014" y="9662"/>
+                  <a:pt x="683570" y="18288"/>
+                </a:cubicBezTo>
+                <a:cubicBezTo>
+                  <a:pt x="371126" y="26914"/>
+                  <a:pt x="198687" y="16167"/>
+                  <a:pt x="0" y="18288"/>
+                </a:cubicBezTo>
+                <a:cubicBezTo>
+                  <a:pt x="843" y="9577"/>
+                  <a:pt x="371" y="6900"/>
+                  <a:pt x="0" y="0"/>
+                </a:cubicBezTo>
+                <a:close/>
+              </a:path>
+            </a:pathLst>
+          </a:custGeom>
+          <a:solidFill>
+            <a:schemeClr val="accent2"/>
+          </a:solidFill>
+          <a:ln w="38100" cap="rnd">
+            <a:solidFill>
+              <a:schemeClr val="accent2"/>
+            </a:solidFill>
+            <a:round/>
+            <a:extLst>
+              <a:ext uri="{C807C97D-BFC1-408E-A445-0C87EB9F89A2}">
+                <ask:lineSketchStyleProps xmlns:ask="http://schemas.microsoft.com/office/drawing/2018/sketchyshapes" sd="1219033472">
+                  <a:prstGeom prst="rect">
+                    <a:avLst/>
+                  </a:prstGeom>
+                  <ask:type>
+                    <ask:lineSketchFreehand/>
+                  </ask:type>
+                </ask:lineSketchStyleProps>
+              </a:ext>
+            </a:extLst>
+          </a:ln>
+        </p:spPr>
+        <p:style>
+          <a:lnRef idx="2">
+            <a:schemeClr val="accent1">
+              <a:shade val="50000"/>
+            </a:schemeClr>
+          </a:lnRef>
+          <a:fillRef idx="1">
+            <a:schemeClr val="accent1"/>
+          </a:fillRef>
+          <a:effectRef idx="0">
+            <a:schemeClr val="accent1"/>
+          </a:effectRef>
+          <a:fontRef idx="minor">
+            <a:schemeClr val="lt1"/>
+          </a:fontRef>
+        </p:style>
+        <p:txBody>
+          <a:bodyPr rtlCol="0" anchor="ctr"/>
+          <a:lstStyle/>
+          <a:p>
+            <a:pPr algn="ctr"/>
+            <a:endParaRPr lang="en-US"/>
+          </a:p>
+        </p:txBody>
+      </p:sp>
+      <p:sp>
+        <p:nvSpPr>
+          <p:cNvPr id="9" name="Content Placeholder 8">
+            <a:extLst>
+              <a:ext uri="{FF2B5EF4-FFF2-40B4-BE49-F238E27FC236}">
+                <a16:creationId xmlns:a16="http://schemas.microsoft.com/office/drawing/2014/main" id="{A265CE1D-EB8C-E765-1820-C5650524DA5C}"/>
+              </a:ext>
+            </a:extLst>
+          </p:cNvPr>
+          <p:cNvSpPr>
+            <a:spLocks noGrp="1"/>
+          </p:cNvSpPr>
+          <p:nvPr>
+            <p:ph idx="1"/>
+          </p:nvPr>
+        </p:nvSpPr>
+        <p:spPr>
+          <a:xfrm>
+            <a:off x="630936" y="2807208"/>
+            <a:ext cx="3429000" cy="3410712"/>
+          </a:xfrm>
+        </p:spPr>
+        <p:txBody>
+          <a:bodyPr anchor="t">
+            <a:normAutofit/>
+          </a:bodyPr>
+          <a:lstStyle/>
+          <a:p>
+            <a:endParaRPr lang="en-US" sz="2200"/>
+          </a:p>
+        </p:txBody>
+      </p:sp>
+      <p:pic>
+        <p:nvPicPr>
+          <p:cNvPr id="5" name="Pladsholder til indhold 4">
+            <a:extLst>
+              <a:ext uri="{FF2B5EF4-FFF2-40B4-BE49-F238E27FC236}">
+                <a16:creationId xmlns:a16="http://schemas.microsoft.com/office/drawing/2014/main" id="{C6D04365-7EBD-F564-6FD6-C8D4D333919E}"/>
+              </a:ext>
+            </a:extLst>
+          </p:cNvPr>
+          <p:cNvPicPr>
+            <a:picLocks noChangeAspect="1"/>
+          </p:cNvPicPr>
+          <p:nvPr/>
+        </p:nvPicPr>
+        <p:blipFill>
+          <a:blip r:embed="rId2">
+            <a:extLst>
+              <a:ext uri="{28A0092B-C50C-407E-A947-70E740481C1C}">
+                <a14:useLocalDpi xmlns:a14="http://schemas.microsoft.com/office/drawing/2010/main" val="0"/>
+              </a:ext>
+            </a:extLst>
+          </a:blip>
+          <a:stretch>
+            <a:fillRect/>
+          </a:stretch>
+        </p:blipFill>
+        <p:spPr>
+          <a:xfrm>
+            <a:off x="4654296" y="788327"/>
+            <a:ext cx="6903720" cy="5281345"/>
+          </a:xfrm>
+          <a:prstGeom prst="rect">
+            <a:avLst/>
+          </a:prstGeom>
+        </p:spPr>
+      </p:pic>
+    </p:spTree>
+    <p:extLst>
+      <p:ext uri="{BB962C8B-B14F-4D97-AF65-F5344CB8AC3E}">
+        <p14:creationId xmlns:p14="http://schemas.microsoft.com/office/powerpoint/2010/main" val="3405534990"/>
+      </p:ext>
+    </p:extLst>
+  </p:cSld>
+  <p:clrMapOvr>
+    <a:masterClrMapping/>
+  </p:clrMapOvr>
+</p:sld>
+</file>
+
+<file path=ppt/slides/slide5.xml><?xml version="1.0" encoding="utf-8"?>
+<p:sld xmlns:a="http://schemas.openxmlformats.org/drawingml/2006/main" xmlns:r="http://schemas.openxmlformats.org/officeDocument/2006/relationships" xmlns:p="http://schemas.openxmlformats.org/presentationml/2006/main">
+  <p:cSld>
+    <p:spTree>
+      <p:nvGrpSpPr>
+        <p:cNvPr id="1" name=""/>
+        <p:cNvGrpSpPr/>
+        <p:nvPr/>
+      </p:nvGrpSpPr>
+      <p:grpSpPr>
+        <a:xfrm>
+          <a:off x="0" y="0"/>
+          <a:ext cx="0" cy="0"/>
+          <a:chOff x="0" y="0"/>
+          <a:chExt cx="0" cy="0"/>
+        </a:xfrm>
+      </p:grpSpPr>
+      <p:sp>
+        <p:nvSpPr>
+          <p:cNvPr id="2" name="Titel 1">
+            <a:extLst>
+              <a:ext uri="{FF2B5EF4-FFF2-40B4-BE49-F238E27FC236}">
+                <a16:creationId xmlns:a16="http://schemas.microsoft.com/office/drawing/2014/main" id="{C246B86E-38E0-54F1-78C5-C1EEA85060A1}"/>
+              </a:ext>
+            </a:extLst>
+          </p:cNvPr>
+          <p:cNvSpPr>
+            <a:spLocks noGrp="1"/>
+          </p:cNvSpPr>
+          <p:nvPr>
+            <p:ph type="title"/>
+          </p:nvPr>
+        </p:nvSpPr>
+        <p:spPr/>
+        <p:txBody>
+          <a:bodyPr/>
+          <a:lstStyle/>
+          <a:p>
+            <a:endParaRPr lang="da-DK" dirty="0"/>
+          </a:p>
+        </p:txBody>
+      </p:sp>
+      <p:pic>
+        <p:nvPicPr>
+          <p:cNvPr id="5" name="Pladsholder til indhold 4">
+            <a:extLst>
+              <a:ext uri="{FF2B5EF4-FFF2-40B4-BE49-F238E27FC236}">
+                <a16:creationId xmlns:a16="http://schemas.microsoft.com/office/drawing/2014/main" id="{2C8BC148-07C3-9CB7-91B1-4FA9BC6952F8}"/>
+              </a:ext>
+            </a:extLst>
+          </p:cNvPr>
+          <p:cNvPicPr>
+            <a:picLocks noGrp="1" noChangeAspect="1"/>
+          </p:cNvPicPr>
+          <p:nvPr>
+            <p:ph idx="1"/>
+          </p:nvPr>
+        </p:nvPicPr>
+        <p:blipFill>
+          <a:blip r:embed="rId2"/>
+          <a:stretch>
+            <a:fillRect/>
+          </a:stretch>
+        </p:blipFill>
+        <p:spPr>
+          <a:xfrm>
+            <a:off x="2416628" y="1784959"/>
+            <a:ext cx="6858000" cy="5073041"/>
+          </a:xfrm>
+          <a:prstGeom prst="rect">
+            <a:avLst/>
+          </a:prstGeom>
+        </p:spPr>
+      </p:pic>
+    </p:spTree>
+    <p:extLst>
+      <p:ext uri="{BB962C8B-B14F-4D97-AF65-F5344CB8AC3E}">
+        <p14:creationId xmlns:p14="http://schemas.microsoft.com/office/powerpoint/2010/main" val="3455264546"/>
       </p:ext>
     </p:extLst>
   </p:cSld>

</xml_diff>

<commit_message>
Changes to chris slides and autoencoder resnet run
</commit_message>
<xml_diff>
--- a/Chris_workspace/Chris slides.pptx
+++ b/Chris_workspace/Chris slides.pptx
@@ -4549,36 +4549,6 @@
           </a:p>
         </p:txBody>
       </p:sp>
-      <p:pic>
-        <p:nvPicPr>
-          <p:cNvPr id="4" name="Picture 3">
-            <a:extLst>
-              <a:ext uri="{FF2B5EF4-FFF2-40B4-BE49-F238E27FC236}">
-                <a16:creationId xmlns:a16="http://schemas.microsoft.com/office/drawing/2014/main" id="{EEEC9AE9-EE6A-1679-A511-A1A4A50937E9}"/>
-              </a:ext>
-            </a:extLst>
-          </p:cNvPr>
-          <p:cNvPicPr>
-            <a:picLocks noChangeAspect="1"/>
-          </p:cNvPicPr>
-          <p:nvPr/>
-        </p:nvPicPr>
-        <p:blipFill>
-          <a:blip r:embed="rId2"/>
-          <a:stretch>
-            <a:fillRect/>
-          </a:stretch>
-        </p:blipFill>
-        <p:spPr>
-          <a:xfrm>
-            <a:off x="448826" y="2932496"/>
-            <a:ext cx="2578285" cy="2300208"/>
-          </a:xfrm>
-          <a:prstGeom prst="rect">
-            <a:avLst/>
-          </a:prstGeom>
-        </p:spPr>
-      </p:pic>
       <p:cxnSp>
         <p:nvCxnSpPr>
           <p:cNvPr id="7" name="Straight Arrow Connector 6">
@@ -4619,36 +4589,6 @@
           </a:fontRef>
         </p:style>
       </p:cxnSp>
-      <p:pic>
-        <p:nvPicPr>
-          <p:cNvPr id="9" name="Picture 8">
-            <a:extLst>
-              <a:ext uri="{FF2B5EF4-FFF2-40B4-BE49-F238E27FC236}">
-                <a16:creationId xmlns:a16="http://schemas.microsoft.com/office/drawing/2014/main" id="{E7E3F1AF-F193-3F8A-EE1F-919A7150579A}"/>
-              </a:ext>
-            </a:extLst>
-          </p:cNvPr>
-          <p:cNvPicPr>
-            <a:picLocks noChangeAspect="1"/>
-          </p:cNvPicPr>
-          <p:nvPr/>
-        </p:nvPicPr>
-        <p:blipFill>
-          <a:blip r:embed="rId3"/>
-          <a:stretch>
-            <a:fillRect/>
-          </a:stretch>
-        </p:blipFill>
-        <p:spPr>
-          <a:xfrm>
-            <a:off x="4086691" y="2932496"/>
-            <a:ext cx="2300209" cy="2300209"/>
-          </a:xfrm>
-          <a:prstGeom prst="rect">
-            <a:avLst/>
-          </a:prstGeom>
-        </p:spPr>
-      </p:pic>
       <p:cxnSp>
         <p:nvCxnSpPr>
           <p:cNvPr id="11" name="Connector: Curved 10">
@@ -4806,6 +4746,53 @@
               </a:rPr>
               <a:t>Scraped image</a:t>
             </a:r>
+          </a:p>
+        </p:txBody>
+      </p:sp>
+      <p:sp>
+        <p:nvSpPr>
+          <p:cNvPr id="20" name="TextBox 19">
+            <a:extLst>
+              <a:ext uri="{FF2B5EF4-FFF2-40B4-BE49-F238E27FC236}">
+                <a16:creationId xmlns:a16="http://schemas.microsoft.com/office/drawing/2014/main" id="{33085376-4467-AD29-E113-93E76FA0378F}"/>
+              </a:ext>
+            </a:extLst>
+          </p:cNvPr>
+          <p:cNvSpPr txBox="1"/>
+          <p:nvPr/>
+        </p:nvSpPr>
+        <p:spPr>
+          <a:xfrm>
+            <a:off x="8449635" y="4181241"/>
+            <a:ext cx="3293539" cy="646331"/>
+          </a:xfrm>
+          <a:prstGeom prst="rect">
+            <a:avLst/>
+          </a:prstGeom>
+          <a:noFill/>
+        </p:spPr>
+        <p:txBody>
+          <a:bodyPr wrap="square" rtlCol="0">
+            <a:spAutoFit/>
+          </a:bodyPr>
+          <a:lstStyle/>
+          <a:p>
+            <a:r>
+              <a:rPr lang="en-GB" dirty="0">
+                <a:latin typeface="Times New Roman" panose="02020603050405020304" pitchFamily="18" charset="0"/>
+                <a:cs typeface="Times New Roman" panose="02020603050405020304" pitchFamily="18" charset="0"/>
+              </a:rPr>
+              <a:t>Centred and set to scrandle.com</a:t>
+            </a:r>
+          </a:p>
+          <a:p>
+            <a:r>
+              <a:rPr lang="en-GB" dirty="0">
+                <a:latin typeface="Times New Roman" panose="02020603050405020304" pitchFamily="18" charset="0"/>
+                <a:cs typeface="Times New Roman" panose="02020603050405020304" pitchFamily="18" charset="0"/>
+              </a:rPr>
+              <a:t>aspect ratio</a:t>
+            </a:r>
             <a:endParaRPr lang="da-DK" dirty="0">
               <a:latin typeface="Times New Roman" panose="02020603050405020304" pitchFamily="18" charset="0"/>
               <a:cs typeface="Times New Roman" panose="02020603050405020304" pitchFamily="18" charset="0"/>
@@ -4813,12 +4800,114 @@
           </a:p>
         </p:txBody>
       </p:sp>
+      <p:sp>
+        <p:nvSpPr>
+          <p:cNvPr id="23" name="TextBox 22">
+            <a:extLst>
+              <a:ext uri="{FF2B5EF4-FFF2-40B4-BE49-F238E27FC236}">
+                <a16:creationId xmlns:a16="http://schemas.microsoft.com/office/drawing/2014/main" id="{F33E2102-13C8-B555-B026-3FF895286842}"/>
+              </a:ext>
+            </a:extLst>
+          </p:cNvPr>
+          <p:cNvSpPr txBox="1"/>
+          <p:nvPr/>
+        </p:nvSpPr>
+        <p:spPr>
+          <a:xfrm>
+            <a:off x="8153083" y="1102939"/>
+            <a:ext cx="3886641" cy="369332"/>
+          </a:xfrm>
+          <a:prstGeom prst="rect">
+            <a:avLst/>
+          </a:prstGeom>
+          <a:noFill/>
+        </p:spPr>
+        <p:txBody>
+          <a:bodyPr wrap="none" rtlCol="0">
+            <a:spAutoFit/>
+          </a:bodyPr>
+          <a:lstStyle/>
+          <a:p>
+            <a:r>
+              <a:rPr lang="en-GB" dirty="0">
+                <a:latin typeface="Times New Roman" panose="02020603050405020304" pitchFamily="18" charset="0"/>
+                <a:cs typeface="Times New Roman" panose="02020603050405020304" pitchFamily="18" charset="0"/>
+              </a:rPr>
+              <a:t>Padded to match largest possible image</a:t>
+            </a:r>
+            <a:endParaRPr lang="da-DK" dirty="0">
+              <a:latin typeface="Times New Roman" panose="02020603050405020304" pitchFamily="18" charset="0"/>
+              <a:cs typeface="Times New Roman" panose="02020603050405020304" pitchFamily="18" charset="0"/>
+            </a:endParaRPr>
+          </a:p>
+        </p:txBody>
+      </p:sp>
       <p:pic>
         <p:nvPicPr>
-          <p:cNvPr id="19" name="Picture 18">
-            <a:extLst>
-              <a:ext uri="{FF2B5EF4-FFF2-40B4-BE49-F238E27FC236}">
-                <a16:creationId xmlns:a16="http://schemas.microsoft.com/office/drawing/2014/main" id="{52517F14-56D6-DC62-5C6F-56C38685A9DA}"/>
+          <p:cNvPr id="8" name="Picture 7">
+            <a:extLst>
+              <a:ext uri="{FF2B5EF4-FFF2-40B4-BE49-F238E27FC236}">
+                <a16:creationId xmlns:a16="http://schemas.microsoft.com/office/drawing/2014/main" id="{D63857ED-31B7-AFE2-415B-C49E2BC325C4}"/>
+              </a:ext>
+            </a:extLst>
+          </p:cNvPr>
+          <p:cNvPicPr>
+            <a:picLocks noChangeAspect="1"/>
+          </p:cNvPicPr>
+          <p:nvPr/>
+        </p:nvPicPr>
+        <p:blipFill>
+          <a:blip r:embed="rId2"/>
+          <a:stretch>
+            <a:fillRect/>
+          </a:stretch>
+        </p:blipFill>
+        <p:spPr>
+          <a:xfrm>
+            <a:off x="400783" y="2932494"/>
+            <a:ext cx="2499733" cy="2378947"/>
+          </a:xfrm>
+          <a:prstGeom prst="rect">
+            <a:avLst/>
+          </a:prstGeom>
+        </p:spPr>
+      </p:pic>
+      <p:pic>
+        <p:nvPicPr>
+          <p:cNvPr id="13" name="Picture 12">
+            <a:extLst>
+              <a:ext uri="{FF2B5EF4-FFF2-40B4-BE49-F238E27FC236}">
+                <a16:creationId xmlns:a16="http://schemas.microsoft.com/office/drawing/2014/main" id="{57A72030-A82E-1632-677C-DC4CAB285789}"/>
+              </a:ext>
+            </a:extLst>
+          </p:cNvPr>
+          <p:cNvPicPr>
+            <a:picLocks noChangeAspect="1"/>
+          </p:cNvPicPr>
+          <p:nvPr/>
+        </p:nvPicPr>
+        <p:blipFill>
+          <a:blip r:embed="rId3"/>
+          <a:stretch>
+            <a:fillRect/>
+          </a:stretch>
+        </p:blipFill>
+        <p:spPr>
+          <a:xfrm>
+            <a:off x="3965398" y="3156920"/>
+            <a:ext cx="2625978" cy="1930094"/>
+          </a:xfrm>
+          <a:prstGeom prst="rect">
+            <a:avLst/>
+          </a:prstGeom>
+        </p:spPr>
+      </p:pic>
+      <p:pic>
+        <p:nvPicPr>
+          <p:cNvPr id="15" name="Picture 14">
+            <a:extLst>
+              <a:ext uri="{FF2B5EF4-FFF2-40B4-BE49-F238E27FC236}">
+                <a16:creationId xmlns:a16="http://schemas.microsoft.com/office/drawing/2014/main" id="{6C709EC1-770C-15D6-A9F2-93224B262757}"/>
               </a:ext>
             </a:extLst>
           </p:cNvPr>
@@ -4835,71 +4924,20 @@
         </p:blipFill>
         <p:spPr>
           <a:xfrm>
-            <a:off x="8809702" y="4827572"/>
-            <a:ext cx="2323871" cy="1936559"/>
+            <a:off x="8985357" y="1524749"/>
+            <a:ext cx="2222092" cy="2604013"/>
           </a:xfrm>
           <a:prstGeom prst="rect">
             <a:avLst/>
           </a:prstGeom>
         </p:spPr>
       </p:pic>
-      <p:sp>
-        <p:nvSpPr>
-          <p:cNvPr id="20" name="TextBox 19">
-            <a:extLst>
-              <a:ext uri="{FF2B5EF4-FFF2-40B4-BE49-F238E27FC236}">
-                <a16:creationId xmlns:a16="http://schemas.microsoft.com/office/drawing/2014/main" id="{33085376-4467-AD29-E113-93E76FA0378F}"/>
-              </a:ext>
-            </a:extLst>
-          </p:cNvPr>
-          <p:cNvSpPr txBox="1"/>
-          <p:nvPr/>
-        </p:nvSpPr>
-        <p:spPr>
-          <a:xfrm>
-            <a:off x="8449635" y="4181241"/>
-            <a:ext cx="3293539" cy="646331"/>
-          </a:xfrm>
-          <a:prstGeom prst="rect">
-            <a:avLst/>
-          </a:prstGeom>
-          <a:noFill/>
-        </p:spPr>
-        <p:txBody>
-          <a:bodyPr wrap="square" rtlCol="0">
-            <a:spAutoFit/>
-          </a:bodyPr>
-          <a:lstStyle/>
-          <a:p>
-            <a:r>
-              <a:rPr lang="en-GB" dirty="0">
-                <a:latin typeface="Times New Roman" panose="02020603050405020304" pitchFamily="18" charset="0"/>
-                <a:cs typeface="Times New Roman" panose="02020603050405020304" pitchFamily="18" charset="0"/>
-              </a:rPr>
-              <a:t>Centred and set to scrandle.com</a:t>
-            </a:r>
-          </a:p>
-          <a:p>
-            <a:r>
-              <a:rPr lang="en-GB" dirty="0">
-                <a:latin typeface="Times New Roman" panose="02020603050405020304" pitchFamily="18" charset="0"/>
-                <a:cs typeface="Times New Roman" panose="02020603050405020304" pitchFamily="18" charset="0"/>
-              </a:rPr>
-              <a:t>aspect ratio</a:t>
-            </a:r>
-            <a:endParaRPr lang="da-DK" dirty="0">
-              <a:latin typeface="Times New Roman" panose="02020603050405020304" pitchFamily="18" charset="0"/>
-              <a:cs typeface="Times New Roman" panose="02020603050405020304" pitchFamily="18" charset="0"/>
-            </a:endParaRPr>
-          </a:p>
-        </p:txBody>
-      </p:sp>
       <p:pic>
         <p:nvPicPr>
-          <p:cNvPr id="22" name="Picture 21">
-            <a:extLst>
-              <a:ext uri="{FF2B5EF4-FFF2-40B4-BE49-F238E27FC236}">
-                <a16:creationId xmlns:a16="http://schemas.microsoft.com/office/drawing/2014/main" id="{2931738F-E579-4891-9ED1-AC59CDB6D204}"/>
+          <p:cNvPr id="21" name="Picture 20">
+            <a:extLst>
+              <a:ext uri="{FF2B5EF4-FFF2-40B4-BE49-F238E27FC236}">
+                <a16:creationId xmlns:a16="http://schemas.microsoft.com/office/drawing/2014/main" id="{14B67928-E426-5A9B-4FDA-D56B03F6B1D5}"/>
               </a:ext>
             </a:extLst>
           </p:cNvPr>
@@ -4916,56 +4954,14 @@
         </p:blipFill>
         <p:spPr>
           <a:xfrm>
-            <a:off x="8809702" y="1573345"/>
-            <a:ext cx="1883159" cy="2206827"/>
+            <a:off x="9011596" y="4827572"/>
+            <a:ext cx="2169613" cy="1808011"/>
           </a:xfrm>
           <a:prstGeom prst="rect">
             <a:avLst/>
           </a:prstGeom>
         </p:spPr>
       </p:pic>
-      <p:sp>
-        <p:nvSpPr>
-          <p:cNvPr id="23" name="TextBox 22">
-            <a:extLst>
-              <a:ext uri="{FF2B5EF4-FFF2-40B4-BE49-F238E27FC236}">
-                <a16:creationId xmlns:a16="http://schemas.microsoft.com/office/drawing/2014/main" id="{F33E2102-13C8-B555-B026-3FF895286842}"/>
-              </a:ext>
-            </a:extLst>
-          </p:cNvPr>
-          <p:cNvSpPr txBox="1"/>
-          <p:nvPr/>
-        </p:nvSpPr>
-        <p:spPr>
-          <a:xfrm>
-            <a:off x="8153083" y="1102939"/>
-            <a:ext cx="3886641" cy="369332"/>
-          </a:xfrm>
-          <a:prstGeom prst="rect">
-            <a:avLst/>
-          </a:prstGeom>
-          <a:noFill/>
-        </p:spPr>
-        <p:txBody>
-          <a:bodyPr wrap="none" rtlCol="0">
-            <a:spAutoFit/>
-          </a:bodyPr>
-          <a:lstStyle/>
-          <a:p>
-            <a:r>
-              <a:rPr lang="en-GB" dirty="0">
-                <a:latin typeface="Times New Roman" panose="02020603050405020304" pitchFamily="18" charset="0"/>
-                <a:cs typeface="Times New Roman" panose="02020603050405020304" pitchFamily="18" charset="0"/>
-              </a:rPr>
-              <a:t>Padded to match largest possible image</a:t>
-            </a:r>
-            <a:endParaRPr lang="da-DK" dirty="0">
-              <a:latin typeface="Times New Roman" panose="02020603050405020304" pitchFamily="18" charset="0"/>
-              <a:cs typeface="Times New Roman" panose="02020603050405020304" pitchFamily="18" charset="0"/>
-            </a:endParaRPr>
-          </a:p>
-        </p:txBody>
-      </p:sp>
     </p:spTree>
     <p:extLst>
       <p:ext uri="{BB962C8B-B14F-4D97-AF65-F5344CB8AC3E}">

</xml_diff>